<commit_message>
Recommend Mac Studio package at CHF 55'000 all-in
Slide 3 now presents a single Mac Studio bundle (2x M5 Ultra, NAS,
microphones, setup, licence and first-year support) instead of three
hardware tiers; slide 2 wording adjusted to on-site Mac Studio.

Co-Authored-By: Claude Opus 5.5 <noreply@anthropic.com>
Claude-Session: https://claude.ai/code/session_01BmLM6LkhwdNVFqBnDhcXTw
</commit_message>
<xml_diff>
--- a/presentations/suisse-meets-onprem/Suisse_Meets_OnPrem_DE.pptx
+++ b/presentations/suisse-meets-onprem/Suisse_Meets_OnPrem_DE.pptx
@@ -831,7 +831,7 @@
                 <a:latin typeface="Arial"/>
                 <a:cs typeface="Arial"/>
               </a:rPr>
-              <a:t>Eine Kopie der Suisse-Meets-Web-App plus KI-Modelle – alles in Ihrem Rechenzentrum.</a:t>
+              <a:t>Eine Kopie der Suisse-Meets-Web-App plus KI-Modelle – alles bei Ihnen vor Ort.</a:t>
             </a:r>
           </a:p>
         </p:txBody>
@@ -900,7 +900,7 @@
                 <a:latin typeface="Arial"/>
                 <a:cs typeface="Arial"/>
               </a:rPr>
-              <a:t>IHR RECHENZENTRUM</a:t>
+              <a:t>BEI IHNEN VOR ORT  ·  MAC STUDIO</a:t>
             </a:r>
           </a:p>
         </p:txBody>
@@ -1372,7 +1372,7 @@
                 <a:latin typeface="Arial"/>
                 <a:cs typeface="Arial"/>
               </a:rPr>
-              <a:t>verschlüsselt, auf Ihren eigenen Servern</a:t>
+              <a:t>verschlüsselt, auf Ihrem eigenen NAS</a:t>
             </a:r>
           </a:p>
         </p:txBody>
@@ -1703,7 +1703,7 @@
                 <a:latin typeface="Arial"/>
                 <a:cs typeface="Arial"/>
               </a:rPr>
-              <a:t>Hardware-Empfehlung</a:t>
+              <a:t>Unsere Empfehlung: Mac Studio</a:t>
             </a:r>
           </a:p>
         </p:txBody>
@@ -1747,50 +1747,54 @@
                 <a:latin typeface="Arial"/>
                 <a:cs typeface="Arial"/>
               </a:rPr>
-              <a:t>Ein Server genügt – alle KI-Modelle laufen lokal auf einer Grafikkarte.</a:t>
-            </a:r>
-          </a:p>
-        </p:txBody>
-      </p:sp>
-      <p:sp>
-        <p:nvSpPr>
-          <p:cNvPr id="9" name="KOMPAKT 9"/>
-          <p:cNvSpPr/>
-          <p:nvPr/>
-        </p:nvSpPr>
-        <p:spPr>
-          <a:xfrm>
-            <a:off x="548640" y="1783080"/>
-            <a:ext cx="3484778" cy="3749040"/>
+              <a:t>Einfach, leise und sofort einsatzbereit – kein Serverraum nötig.</a:t>
+            </a:r>
+          </a:p>
+        </p:txBody>
+      </p:sp>
+      <p:sp>
+        <p:nvSpPr>
+          <p:cNvPr id="9" name="Komplettpaket 9"/>
+          <p:cNvSpPr/>
+          <p:nvPr/>
+        </p:nvSpPr>
+        <p:spPr>
+          <a:xfrm>
+            <a:off x="548640" y="1691640"/>
+            <a:ext cx="5486400" cy="4069080"/>
           </a:xfrm>
           <a:prstGeom prst="roundRect">
             <a:avLst>
-              <a:gd name="adj" fmla="val 5000"/>
+              <a:gd name="adj" fmla="val 4000"/>
             </a:avLst>
           </a:prstGeom>
           <a:solidFill>
-            <a:srgbClr val="F2F3F5"/>
-          </a:solidFill>
-          <a:ln>
-            <a:noFill/>
-          </a:ln>
-        </p:spPr>
-      </p:sp>
-      <p:sp>
-        <p:nvSpPr>
-          <p:cNvPr id="10" name="Text 10"/>
-          <p:cNvSpPr txBox="1"/>
-          <p:nvPr/>
-        </p:nvSpPr>
-        <p:spPr>
-          <a:xfrm>
-            <a:off x="868680" y="2103120"/>
-            <a:ext cx="2286000" cy="329184"/>
-          </a:xfrm>
-          <a:prstGeom prst="rect">
-            <a:avLst/>
-          </a:prstGeom>
-          <a:noFill/>
+            <a:srgbClr val="0F1115"/>
+          </a:solidFill>
+          <a:ln>
+            <a:noFill/>
+          </a:ln>
+        </p:spPr>
+      </p:sp>
+      <p:sp>
+        <p:nvSpPr>
+          <p:cNvPr id="10" name="Shape 10"/>
+          <p:cNvSpPr/>
+          <p:nvPr/>
+        </p:nvSpPr>
+        <p:spPr>
+          <a:xfrm>
+            <a:off x="914400" y="2011680"/>
+            <a:ext cx="1783080" cy="329184"/>
+          </a:xfrm>
+          <a:prstGeom prst="roundRect">
+            <a:avLst>
+              <a:gd name="adj" fmla="val 50000"/>
+            </a:avLst>
+          </a:prstGeom>
+          <a:solidFill>
+            <a:srgbClr val="D52B1E"/>
+          </a:solidFill>
           <a:ln>
             <a:noFill/>
           </a:ln>
@@ -1801,7 +1805,7 @@
           </a:bodyPr>
           <a:lstStyle/>
           <a:p>
-            <a:pPr algn="l">
+            <a:pPr algn="ctr">
               <a:spcAft>
                 <a:spcPts val="0"/>
               </a:spcAft>
@@ -1810,12 +1814,12 @@
             <a:r>
               <a:rPr lang="de-CH" sz="1100" b="1" spc="120" dirty="0">
                 <a:solidFill>
-                  <a:srgbClr val="5B6470"/>
-                </a:solidFill>
-                <a:latin typeface="Arial"/>
-                <a:cs typeface="Arial"/>
-              </a:rPr>
-              <a:t>KOMPAKT</a:t>
+                  <a:srgbClr val="FFFFFF"/>
+                </a:solidFill>
+                <a:latin typeface="Arial"/>
+                <a:cs typeface="Arial"/>
+              </a:rPr>
+              <a:t>KOMPLETTPAKET</a:t>
             </a:r>
           </a:p>
         </p:txBody>
@@ -1828,8 +1832,8 @@
         </p:nvSpPr>
         <p:spPr>
           <a:xfrm>
-            <a:off x="868680" y="2606040"/>
-            <a:ext cx="2844698" cy="960120"/>
+            <a:off x="914400" y="2468880"/>
+            <a:ext cx="4754880" cy="777240"/>
           </a:xfrm>
           <a:prstGeom prst="rect">
             <a:avLst/>
@@ -1840,44 +1844,26 @@
           </a:ln>
         </p:spPr>
         <p:txBody>
-          <a:bodyPr wrap="square" lIns="0" tIns="0" rIns="0" bIns="0" rtlCol="0" anchor="t">
-            <a:noAutofit/>
-          </a:bodyPr>
-          <a:lstStyle/>
-          <a:p>
-            <a:pPr algn="l">
-              <a:spcAft>
-                <a:spcPts val="200"/>
-              </a:spcAft>
-              <a:buNone/>
-            </a:pPr>
-            <a:r>
-              <a:rPr lang="de-CH" sz="2600" b="1" dirty="0">
-                <a:solidFill>
-                  <a:srgbClr val="1F2328"/>
-                </a:solidFill>
-                <a:latin typeface="Arial"/>
-                <a:cs typeface="Arial"/>
-              </a:rPr>
-              <a:t>Mac Studio</a:t>
-            </a:r>
-          </a:p>
-          <a:p>
-            <a:pPr algn="l">
-              <a:spcAft>
-                <a:spcPts val="0"/>
-              </a:spcAft>
-              <a:buNone/>
-            </a:pPr>
-            <a:r>
-              <a:rPr lang="de-CH" sz="1500" dirty="0">
-                <a:solidFill>
-                  <a:srgbClr val="5B6470"/>
-                </a:solidFill>
-                <a:latin typeface="Arial"/>
-                <a:cs typeface="Arial"/>
-              </a:rPr>
-              <a:t>M5 Ultra · 96 GB</a:t>
+          <a:bodyPr wrap="square" lIns="0" tIns="0" rIns="0" bIns="0" rtlCol="0" anchor="ctr">
+            <a:noAutofit/>
+          </a:bodyPr>
+          <a:lstStyle/>
+          <a:p>
+            <a:pPr algn="l">
+              <a:spcAft>
+                <a:spcPts val="0"/>
+              </a:spcAft>
+              <a:buNone/>
+            </a:pPr>
+            <a:r>
+              <a:rPr lang="de-CH" sz="4400" b="1" dirty="0">
+                <a:solidFill>
+                  <a:srgbClr val="FFFFFF"/>
+                </a:solidFill>
+                <a:latin typeface="Arial"/>
+                <a:cs typeface="Arial"/>
+              </a:rPr>
+              <a:t>CHF 55'000</a:t>
             </a:r>
           </a:p>
         </p:txBody>
@@ -1890,8 +1876,8 @@
         </p:nvSpPr>
         <p:spPr>
           <a:xfrm>
-            <a:off x="868680" y="3657600"/>
-            <a:ext cx="2844698" cy="822960"/>
+            <a:off x="914400" y="3246120"/>
+            <a:ext cx="4754880" cy="320040"/>
           </a:xfrm>
           <a:prstGeom prst="rect">
             <a:avLst/>
@@ -1902,12 +1888,56 @@
           </a:ln>
         </p:spPr>
         <p:txBody>
+          <a:bodyPr wrap="square" lIns="0" tIns="0" rIns="0" bIns="0" rtlCol="0" anchor="ctr">
+            <a:noAutofit/>
+          </a:bodyPr>
+          <a:lstStyle/>
+          <a:p>
+            <a:pPr algn="l">
+              <a:spcAft>
+                <a:spcPts val="0"/>
+              </a:spcAft>
+              <a:buNone/>
+            </a:pPr>
+            <a:r>
+              <a:rPr lang="de-CH" sz="1400" dirty="0">
+                <a:solidFill>
+                  <a:srgbClr val="A3ABB6"/>
+                </a:solidFill>
+                <a:latin typeface="Arial"/>
+                <a:cs typeface="Arial"/>
+              </a:rPr>
+              <a:t>einmalig, inkl. Hardware, exkl. MWST</a:t>
+            </a:r>
+          </a:p>
+        </p:txBody>
+      </p:sp>
+      <p:sp>
+        <p:nvSpPr>
+          <p:cNvPr id="13" name="Text 13"/>
+          <p:cNvSpPr txBox="1"/>
+          <p:nvPr/>
+        </p:nvSpPr>
+        <p:spPr>
+          <a:xfrm>
+            <a:off x="914400" y="3794760"/>
+            <a:ext cx="4754880" cy="1783080"/>
+          </a:xfrm>
+          <a:prstGeom prst="rect">
+            <a:avLst/>
+          </a:prstGeom>
+          <a:noFill/>
+          <a:ln>
+            <a:noFill/>
+          </a:ln>
+        </p:spPr>
+        <p:txBody>
           <a:bodyPr wrap="square" lIns="0" tIns="0" rIns="0" bIns="0" rtlCol="0" anchor="t">
             <a:noAutofit/>
           </a:bodyPr>
           <a:lstStyle/>
           <a:p>
-            <a:pPr algn="l" marL="201168" indent="-201168">
+            <a:pPr algn="l" marL="219456" indent="-219456">
               <a:spcAft>
                 <a:spcPts val="600"/>
               </a:spcAft>
@@ -1918,18 +1948,18 @@
               <a:buChar char="•"/>
             </a:pPr>
             <a:r>
-              <a:rPr lang="de-CH" sz="1600" dirty="0">
-                <a:solidFill>
-                  <a:srgbClr val="1F2328"/>
-                </a:solidFill>
-                <a:latin typeface="Arial"/>
-                <a:cs typeface="Arial"/>
-              </a:rPr>
-              <a:t>bis ca. 30 Nutzer</a:t>
-            </a:r>
-          </a:p>
-          <a:p>
-            <a:pPr algn="l" marL="201168" indent="-201168">
+              <a:rPr lang="de-CH" sz="1500" dirty="0">
+                <a:solidFill>
+                  <a:srgbClr val="FFFFFF"/>
+                </a:solidFill>
+                <a:latin typeface="Arial"/>
+                <a:cs typeface="Arial"/>
+              </a:rPr>
+              <a:t>2 × Mac Studio M5 Ultra, 256 GB – redundant</a:t>
+            </a:r>
+          </a:p>
+          <a:p>
+            <a:pPr algn="l" marL="219456" indent="-219456">
               <a:spcAft>
                 <a:spcPts val="600"/>
               </a:spcAft>
@@ -1940,222 +1970,18 @@
               <a:buChar char="•"/>
             </a:pPr>
             <a:r>
-              <a:rPr lang="de-CH" sz="1600" dirty="0">
-                <a:solidFill>
-                  <a:srgbClr val="1F2328"/>
-                </a:solidFill>
-                <a:latin typeface="Arial"/>
-                <a:cs typeface="Arial"/>
-              </a:rPr>
-              <a:t>2–3 parallele Sitzungen</a:t>
-            </a:r>
-          </a:p>
-        </p:txBody>
-      </p:sp>
-      <p:sp>
-        <p:nvSpPr>
-          <p:cNvPr id="13" name="Text 13"/>
-          <p:cNvSpPr txBox="1"/>
-          <p:nvPr/>
-        </p:nvSpPr>
-        <p:spPr>
-          <a:xfrm>
-            <a:off x="868680" y="4663440"/>
-            <a:ext cx="2844698" cy="594360"/>
-          </a:xfrm>
-          <a:prstGeom prst="rect">
-            <a:avLst/>
-          </a:prstGeom>
-          <a:noFill/>
-          <a:ln>
-            <a:noFill/>
-          </a:ln>
-        </p:spPr>
-        <p:txBody>
-          <a:bodyPr wrap="square" lIns="0" tIns="0" rIns="0" bIns="0" rtlCol="0" anchor="ctr">
-            <a:noAutofit/>
-          </a:bodyPr>
-          <a:lstStyle/>
-          <a:p>
-            <a:pPr algn="l">
-              <a:spcAft>
-                <a:spcPts val="0"/>
-              </a:spcAft>
-              <a:buNone/>
-            </a:pPr>
-            <a:r>
-              <a:rPr lang="de-CH" sz="2800" b="1" dirty="0">
-                <a:solidFill>
-                  <a:srgbClr val="1F2328"/>
-                </a:solidFill>
-                <a:latin typeface="Arial"/>
-                <a:cs typeface="Arial"/>
-              </a:rPr>
-              <a:t>CHF 6–8k</a:t>
-            </a:r>
-          </a:p>
-        </p:txBody>
-      </p:sp>
-      <p:sp>
-        <p:nvSpPr>
-          <p:cNvPr id="14" name="EMPFOHLEN 14"/>
-          <p:cNvSpPr/>
-          <p:nvPr/>
-        </p:nvSpPr>
-        <p:spPr>
-          <a:xfrm>
-            <a:off x="4353458" y="1783080"/>
-            <a:ext cx="3484778" cy="3749040"/>
-          </a:xfrm>
-          <a:prstGeom prst="roundRect">
-            <a:avLst>
-              <a:gd name="adj" fmla="val 5000"/>
-            </a:avLst>
-          </a:prstGeom>
-          <a:solidFill>
-            <a:srgbClr val="0F1115"/>
-          </a:solidFill>
-          <a:ln>
-            <a:noFill/>
-          </a:ln>
-        </p:spPr>
-      </p:sp>
-      <p:sp>
-        <p:nvSpPr>
-          <p:cNvPr id="15" name="Shape 15"/>
-          <p:cNvSpPr/>
-          <p:nvPr/>
-        </p:nvSpPr>
-        <p:spPr>
-          <a:xfrm>
-            <a:off x="4673498" y="2103120"/>
-            <a:ext cx="1417320" cy="329184"/>
-          </a:xfrm>
-          <a:prstGeom prst="roundRect">
-            <a:avLst>
-              <a:gd name="adj" fmla="val 50000"/>
-            </a:avLst>
-          </a:prstGeom>
-          <a:solidFill>
-            <a:srgbClr val="D52B1E"/>
-          </a:solidFill>
-          <a:ln>
-            <a:noFill/>
-          </a:ln>
-        </p:spPr>
-        <p:txBody>
-          <a:bodyPr wrap="square" lIns="0" tIns="0" rIns="0" bIns="0" rtlCol="0" anchor="ctr">
-            <a:noAutofit/>
-          </a:bodyPr>
-          <a:lstStyle/>
-          <a:p>
-            <a:pPr algn="ctr">
-              <a:spcAft>
-                <a:spcPts val="0"/>
-              </a:spcAft>
-              <a:buNone/>
-            </a:pPr>
-            <a:r>
-              <a:rPr lang="de-CH" sz="1100" b="1" spc="120" dirty="0">
+              <a:rPr lang="de-CH" sz="1500" dirty="0">
                 <a:solidFill>
                   <a:srgbClr val="FFFFFF"/>
                 </a:solidFill>
                 <a:latin typeface="Arial"/>
                 <a:cs typeface="Arial"/>
               </a:rPr>
-              <a:t>EMPFOHLEN</a:t>
-            </a:r>
-          </a:p>
-        </p:txBody>
-      </p:sp>
-      <p:sp>
-        <p:nvSpPr>
-          <p:cNvPr id="16" name="Text 16"/>
-          <p:cNvSpPr txBox="1"/>
-          <p:nvPr/>
-        </p:nvSpPr>
-        <p:spPr>
-          <a:xfrm>
-            <a:off x="4673498" y="2606040"/>
-            <a:ext cx="2844698" cy="960120"/>
-          </a:xfrm>
-          <a:prstGeom prst="rect">
-            <a:avLst/>
-          </a:prstGeom>
-          <a:noFill/>
-          <a:ln>
-            <a:noFill/>
-          </a:ln>
-        </p:spPr>
-        <p:txBody>
-          <a:bodyPr wrap="square" lIns="0" tIns="0" rIns="0" bIns="0" rtlCol="0" anchor="t">
-            <a:noAutofit/>
-          </a:bodyPr>
-          <a:lstStyle/>
-          <a:p>
-            <a:pPr algn="l">
-              <a:spcAft>
-                <a:spcPts val="200"/>
-              </a:spcAft>
-              <a:buNone/>
-            </a:pPr>
-            <a:r>
-              <a:rPr lang="de-CH" sz="2600" b="1" dirty="0">
-                <a:solidFill>
-                  <a:srgbClr val="FFFFFF"/>
-                </a:solidFill>
-                <a:latin typeface="Arial"/>
-                <a:cs typeface="Arial"/>
-              </a:rPr>
-              <a:t>GPU-Server</a:t>
-            </a:r>
-          </a:p>
-          <a:p>
-            <a:pPr algn="l">
-              <a:spcAft>
-                <a:spcPts val="0"/>
-              </a:spcAft>
-              <a:buNone/>
-            </a:pPr>
-            <a:r>
-              <a:rPr lang="de-CH" sz="1500" dirty="0">
-                <a:solidFill>
-                  <a:srgbClr val="D3D8DF"/>
-                </a:solidFill>
-                <a:latin typeface="Arial"/>
-                <a:cs typeface="Arial"/>
-              </a:rPr>
-              <a:t>NVIDIA RTX PRO 6000 · 96 GB</a:t>
-            </a:r>
-          </a:p>
-        </p:txBody>
-      </p:sp>
-      <p:sp>
-        <p:nvSpPr>
-          <p:cNvPr id="17" name="Text 17"/>
-          <p:cNvSpPr txBox="1"/>
-          <p:nvPr/>
-        </p:nvSpPr>
-        <p:spPr>
-          <a:xfrm>
-            <a:off x="4673498" y="3657600"/>
-            <a:ext cx="2844698" cy="822960"/>
-          </a:xfrm>
-          <a:prstGeom prst="rect">
-            <a:avLst/>
-          </a:prstGeom>
-          <a:noFill/>
-          <a:ln>
-            <a:noFill/>
-          </a:ln>
-        </p:spPr>
-        <p:txBody>
-          <a:bodyPr wrap="square" lIns="0" tIns="0" rIns="0" bIns="0" rtlCol="0" anchor="t">
-            <a:noAutofit/>
-          </a:bodyPr>
-          <a:lstStyle/>
-          <a:p>
-            <a:pPr algn="l" marL="201168" indent="-201168">
+              <a:t>NAS-Speicher mit Backup und USV</a:t>
+            </a:r>
+          </a:p>
+          <a:p>
+            <a:pPr algn="l" marL="219456" indent="-219456">
               <a:spcAft>
                 <a:spcPts val="600"/>
               </a:spcAft>
@@ -2166,18 +1992,18 @@
               <a:buChar char="•"/>
             </a:pPr>
             <a:r>
-              <a:rPr lang="de-CH" sz="1600" dirty="0">
+              <a:rPr lang="de-CH" sz="1500" dirty="0">
                 <a:solidFill>
                   <a:srgbClr val="FFFFFF"/>
                 </a:solidFill>
                 <a:latin typeface="Arial"/>
                 <a:cs typeface="Arial"/>
               </a:rPr>
-              <a:t>50–300 Nutzer</a:t>
-            </a:r>
-          </a:p>
-          <a:p>
-            <a:pPr algn="l" marL="201168" indent="-201168">
+              <a:t>Konferenzmikrofone für 5 Sitzungszimmer</a:t>
+            </a:r>
+          </a:p>
+          <a:p>
+            <a:pPr algn="l" marL="219456" indent="-219456">
               <a:spcAft>
                 <a:spcPts val="600"/>
               </a:spcAft>
@@ -2188,218 +2014,18 @@
               <a:buChar char="•"/>
             </a:pPr>
             <a:r>
-              <a:rPr lang="de-CH" sz="1600" dirty="0">
+              <a:rPr lang="de-CH" sz="1500" dirty="0">
                 <a:solidFill>
                   <a:srgbClr val="FFFFFF"/>
                 </a:solidFill>
                 <a:latin typeface="Arial"/>
                 <a:cs typeface="Arial"/>
               </a:rPr>
-              <a:t>~15 parallele Sitzungen</a:t>
-            </a:r>
-          </a:p>
-        </p:txBody>
-      </p:sp>
-      <p:sp>
-        <p:nvSpPr>
-          <p:cNvPr id="18" name="Text 18"/>
-          <p:cNvSpPr txBox="1"/>
-          <p:nvPr/>
-        </p:nvSpPr>
-        <p:spPr>
-          <a:xfrm>
-            <a:off x="4673498" y="4663440"/>
-            <a:ext cx="2844698" cy="594360"/>
-          </a:xfrm>
-          <a:prstGeom prst="rect">
-            <a:avLst/>
-          </a:prstGeom>
-          <a:noFill/>
-          <a:ln>
-            <a:noFill/>
-          </a:ln>
-        </p:spPr>
-        <p:txBody>
-          <a:bodyPr wrap="square" lIns="0" tIns="0" rIns="0" bIns="0" rtlCol="0" anchor="ctr">
-            <a:noAutofit/>
-          </a:bodyPr>
-          <a:lstStyle/>
-          <a:p>
-            <a:pPr algn="l">
-              <a:spcAft>
-                <a:spcPts val="0"/>
-              </a:spcAft>
-              <a:buNone/>
-            </a:pPr>
-            <a:r>
-              <a:rPr lang="de-CH" sz="2800" b="1" dirty="0">
-                <a:solidFill>
-                  <a:srgbClr val="FFFFFF"/>
-                </a:solidFill>
-                <a:latin typeface="Arial"/>
-                <a:cs typeface="Arial"/>
-              </a:rPr>
-              <a:t>CHF 25–40k</a:t>
-            </a:r>
-          </a:p>
-        </p:txBody>
-      </p:sp>
-      <p:sp>
-        <p:nvSpPr>
-          <p:cNvPr id="19" name="ENTERPRISE 19"/>
-          <p:cNvSpPr/>
-          <p:nvPr/>
-        </p:nvSpPr>
-        <p:spPr>
-          <a:xfrm>
-            <a:off x="8158277" y="1783080"/>
-            <a:ext cx="3484778" cy="3749040"/>
-          </a:xfrm>
-          <a:prstGeom prst="roundRect">
-            <a:avLst>
-              <a:gd name="adj" fmla="val 5000"/>
-            </a:avLst>
-          </a:prstGeom>
-          <a:solidFill>
-            <a:srgbClr val="F2F3F5"/>
-          </a:solidFill>
-          <a:ln>
-            <a:noFill/>
-          </a:ln>
-        </p:spPr>
-      </p:sp>
-      <p:sp>
-        <p:nvSpPr>
-          <p:cNvPr id="20" name="Text 20"/>
-          <p:cNvSpPr txBox="1"/>
-          <p:nvPr/>
-        </p:nvSpPr>
-        <p:spPr>
-          <a:xfrm>
-            <a:off x="8478317" y="2103120"/>
-            <a:ext cx="2286000" cy="329184"/>
-          </a:xfrm>
-          <a:prstGeom prst="rect">
-            <a:avLst/>
-          </a:prstGeom>
-          <a:noFill/>
-          <a:ln>
-            <a:noFill/>
-          </a:ln>
-        </p:spPr>
-        <p:txBody>
-          <a:bodyPr wrap="square" lIns="0" tIns="0" rIns="0" bIns="0" rtlCol="0" anchor="ctr">
-            <a:noAutofit/>
-          </a:bodyPr>
-          <a:lstStyle/>
-          <a:p>
-            <a:pPr algn="l">
-              <a:spcAft>
-                <a:spcPts val="0"/>
-              </a:spcAft>
-              <a:buNone/>
-            </a:pPr>
-            <a:r>
-              <a:rPr lang="de-CH" sz="1100" b="1" spc="120" dirty="0">
-                <a:solidFill>
-                  <a:srgbClr val="5B6470"/>
-                </a:solidFill>
-                <a:latin typeface="Arial"/>
-                <a:cs typeface="Arial"/>
-              </a:rPr>
-              <a:t>ENTERPRISE</a:t>
-            </a:r>
-          </a:p>
-        </p:txBody>
-      </p:sp>
-      <p:sp>
-        <p:nvSpPr>
-          <p:cNvPr id="21" name="Text 21"/>
-          <p:cNvSpPr txBox="1"/>
-          <p:nvPr/>
-        </p:nvSpPr>
-        <p:spPr>
-          <a:xfrm>
-            <a:off x="8478317" y="2606040"/>
-            <a:ext cx="2844698" cy="960120"/>
-          </a:xfrm>
-          <a:prstGeom prst="rect">
-            <a:avLst/>
-          </a:prstGeom>
-          <a:noFill/>
-          <a:ln>
-            <a:noFill/>
-          </a:ln>
-        </p:spPr>
-        <p:txBody>
-          <a:bodyPr wrap="square" lIns="0" tIns="0" rIns="0" bIns="0" rtlCol="0" anchor="t">
-            <a:noAutofit/>
-          </a:bodyPr>
-          <a:lstStyle/>
-          <a:p>
-            <a:pPr algn="l">
-              <a:spcAft>
-                <a:spcPts val="200"/>
-              </a:spcAft>
-              <a:buNone/>
-            </a:pPr>
-            <a:r>
-              <a:rPr lang="de-CH" sz="2600" b="1" dirty="0">
-                <a:solidFill>
-                  <a:srgbClr val="1F2328"/>
-                </a:solidFill>
-                <a:latin typeface="Arial"/>
-                <a:cs typeface="Arial"/>
-              </a:rPr>
-              <a:t>2 GPU-Server</a:t>
-            </a:r>
-          </a:p>
-          <a:p>
-            <a:pPr algn="l">
-              <a:spcAft>
-                <a:spcPts val="0"/>
-              </a:spcAft>
-              <a:buNone/>
-            </a:pPr>
-            <a:r>
-              <a:rPr lang="de-CH" sz="1500" dirty="0">
-                <a:solidFill>
-                  <a:srgbClr val="5B6470"/>
-                </a:solidFill>
-                <a:latin typeface="Arial"/>
-                <a:cs typeface="Arial"/>
-              </a:rPr>
-              <a:t>redundant, ohne Ausfallpunkt</a:t>
-            </a:r>
-          </a:p>
-        </p:txBody>
-      </p:sp>
-      <p:sp>
-        <p:nvSpPr>
-          <p:cNvPr id="22" name="Text 22"/>
-          <p:cNvSpPr txBox="1"/>
-          <p:nvPr/>
-        </p:nvSpPr>
-        <p:spPr>
-          <a:xfrm>
-            <a:off x="8478317" y="3657600"/>
-            <a:ext cx="2844698" cy="822960"/>
-          </a:xfrm>
-          <a:prstGeom prst="rect">
-            <a:avLst/>
-          </a:prstGeom>
-          <a:noFill/>
-          <a:ln>
-            <a:noFill/>
-          </a:ln>
-        </p:spPr>
-        <p:txBody>
-          <a:bodyPr wrap="square" lIns="0" tIns="0" rIns="0" bIns="0" rtlCol="0" anchor="t">
-            <a:noAutofit/>
-          </a:bodyPr>
-          <a:lstStyle/>
-          <a:p>
-            <a:pPr algn="l" marL="201168" indent="-201168">
+              <a:t>Installation, Integration und Schulung</a:t>
+            </a:r>
+          </a:p>
+          <a:p>
+            <a:pPr algn="l" marL="219456" indent="-219456">
               <a:spcAft>
                 <a:spcPts val="600"/>
               </a:spcAft>
@@ -2410,50 +2036,340 @@
               <a:buChar char="•"/>
             </a:pPr>
             <a:r>
-              <a:rPr lang="de-CH" sz="1600" dirty="0">
+              <a:rPr lang="de-CH" sz="1500" dirty="0">
+                <a:solidFill>
+                  <a:srgbClr val="FFFFFF"/>
+                </a:solidFill>
+                <a:latin typeface="Arial"/>
+                <a:cs typeface="Arial"/>
+              </a:rPr>
+              <a:t>Suisse Meets Lizenz und Support im 1. Jahr</a:t>
+            </a:r>
+          </a:p>
+        </p:txBody>
+      </p:sp>
+      <p:sp>
+        <p:nvSpPr>
+          <p:cNvPr id="14" name="Text 14"/>
+          <p:cNvSpPr txBox="1"/>
+          <p:nvPr/>
+        </p:nvSpPr>
+        <p:spPr>
+          <a:xfrm>
+            <a:off x="6446520" y="1691640"/>
+            <a:ext cx="5196535" cy="274320"/>
+          </a:xfrm>
+          <a:prstGeom prst="rect">
+            <a:avLst/>
+          </a:prstGeom>
+          <a:noFill/>
+          <a:ln>
+            <a:noFill/>
+          </a:ln>
+        </p:spPr>
+        <p:txBody>
+          <a:bodyPr wrap="square" lIns="0" tIns="0" rIns="0" bIns="0" rtlCol="0" anchor="ctr">
+            <a:noAutofit/>
+          </a:bodyPr>
+          <a:lstStyle/>
+          <a:p>
+            <a:pPr algn="l">
+              <a:spcAft>
+                <a:spcPts val="0"/>
+              </a:spcAft>
+              <a:buNone/>
+            </a:pPr>
+            <a:r>
+              <a:rPr lang="de-CH" sz="1200" b="1" spc="150" dirty="0">
+                <a:solidFill>
+                  <a:srgbClr val="D52B1E"/>
+                </a:solidFill>
+                <a:latin typeface="Arial"/>
+                <a:cs typeface="Arial"/>
+              </a:rPr>
+              <a:t>WARUM MAC STUDIO?</a:t>
+            </a:r>
+          </a:p>
+        </p:txBody>
+      </p:sp>
+      <p:sp>
+        <p:nvSpPr>
+          <p:cNvPr id="15" name="Shape 15"/>
+          <p:cNvSpPr/>
+          <p:nvPr/>
+        </p:nvSpPr>
+        <p:spPr>
+          <a:xfrm>
+            <a:off x="6446520" y="2148840"/>
+            <a:ext cx="420624" cy="420624"/>
+          </a:xfrm>
+          <a:prstGeom prst="ellipse">
+            <a:avLst/>
+          </a:prstGeom>
+          <a:solidFill>
+            <a:srgbClr val="D52B1E"/>
+          </a:solidFill>
+          <a:ln>
+            <a:noFill/>
+          </a:ln>
+        </p:spPr>
+        <p:txBody>
+          <a:bodyPr wrap="square" lIns="0" tIns="0" rIns="0" bIns="0" rtlCol="0" anchor="ctr">
+            <a:noAutofit/>
+          </a:bodyPr>
+          <a:lstStyle/>
+          <a:p>
+            <a:pPr algn="ctr">
+              <a:spcAft>
+                <a:spcPts val="0"/>
+              </a:spcAft>
+              <a:buNone/>
+            </a:pPr>
+            <a:r>
+              <a:rPr lang="de-CH" sz="1500" b="1" dirty="0">
+                <a:solidFill>
+                  <a:srgbClr val="FFFFFF"/>
+                </a:solidFill>
+                <a:latin typeface="Arial"/>
+                <a:cs typeface="Arial"/>
+              </a:rPr>
+              <a:t>1</a:t>
+            </a:r>
+          </a:p>
+        </p:txBody>
+      </p:sp>
+      <p:sp>
+        <p:nvSpPr>
+          <p:cNvPr id="16" name="Text 16"/>
+          <p:cNvSpPr txBox="1"/>
+          <p:nvPr/>
+        </p:nvSpPr>
+        <p:spPr>
+          <a:xfrm>
+            <a:off x="7040880" y="2103120"/>
+            <a:ext cx="4602175" cy="777240"/>
+          </a:xfrm>
+          <a:prstGeom prst="rect">
+            <a:avLst/>
+          </a:prstGeom>
+          <a:noFill/>
+          <a:ln>
+            <a:noFill/>
+          </a:ln>
+        </p:spPr>
+        <p:txBody>
+          <a:bodyPr wrap="square" lIns="0" tIns="0" rIns="0" bIns="0" rtlCol="0" anchor="t">
+            <a:noAutofit/>
+          </a:bodyPr>
+          <a:lstStyle/>
+          <a:p>
+            <a:pPr algn="l">
+              <a:spcAft>
+                <a:spcPts val="200"/>
+              </a:spcAft>
+              <a:buNone/>
+            </a:pPr>
+            <a:r>
+              <a:rPr lang="de-CH" sz="1700" b="1" dirty="0">
                 <a:solidFill>
                   <a:srgbClr val="1F2328"/>
                 </a:solidFill>
                 <a:latin typeface="Arial"/>
                 <a:cs typeface="Arial"/>
               </a:rPr>
-              <a:t>300–1'500 Nutzer</a:t>
-            </a:r>
-          </a:p>
-          <a:p>
-            <a:pPr algn="l" marL="201168" indent="-201168">
-              <a:spcAft>
-                <a:spcPts val="600"/>
-              </a:spcAft>
-              <a:buClr>
-                <a:srgbClr val="D52B1E"/>
-              </a:buClr>
-              <a:buFont typeface="Arial"/>
-              <a:buChar char="•"/>
-            </a:pPr>
-            <a:r>
-              <a:rPr lang="de-CH" sz="1600" dirty="0">
+              <a:t>Einfach</a:t>
+            </a:r>
+          </a:p>
+          <a:p>
+            <a:pPr algn="l">
+              <a:lnSpc>
+                <a:spcPct val="105000"/>
+              </a:lnSpc>
+              <a:spcAft>
+                <a:spcPts val="0"/>
+              </a:spcAft>
+              <a:buNone/>
+            </a:pPr>
+            <a:r>
+              <a:rPr lang="de-CH" sz="1350" dirty="0">
+                <a:solidFill>
+                  <a:srgbClr val="5B6470"/>
+                </a:solidFill>
+                <a:latin typeface="Arial"/>
+                <a:cs typeface="Arial"/>
+              </a:rPr>
+              <a:t>Plug &amp; Play – kein Serverraum, kein Rack, keine Spezialkühlung.</a:t>
+            </a:r>
+          </a:p>
+        </p:txBody>
+      </p:sp>
+      <p:sp>
+        <p:nvSpPr>
+          <p:cNvPr id="17" name="Shape 17"/>
+          <p:cNvSpPr/>
+          <p:nvPr/>
+        </p:nvSpPr>
+        <p:spPr>
+          <a:xfrm>
+            <a:off x="6446520" y="3017520"/>
+            <a:ext cx="420624" cy="420624"/>
+          </a:xfrm>
+          <a:prstGeom prst="ellipse">
+            <a:avLst/>
+          </a:prstGeom>
+          <a:solidFill>
+            <a:srgbClr val="D52B1E"/>
+          </a:solidFill>
+          <a:ln>
+            <a:noFill/>
+          </a:ln>
+        </p:spPr>
+        <p:txBody>
+          <a:bodyPr wrap="square" lIns="0" tIns="0" rIns="0" bIns="0" rtlCol="0" anchor="ctr">
+            <a:noAutofit/>
+          </a:bodyPr>
+          <a:lstStyle/>
+          <a:p>
+            <a:pPr algn="ctr">
+              <a:spcAft>
+                <a:spcPts val="0"/>
+              </a:spcAft>
+              <a:buNone/>
+            </a:pPr>
+            <a:r>
+              <a:rPr lang="de-CH" sz="1500" b="1" dirty="0">
+                <a:solidFill>
+                  <a:srgbClr val="FFFFFF"/>
+                </a:solidFill>
+                <a:latin typeface="Arial"/>
+                <a:cs typeface="Arial"/>
+              </a:rPr>
+              <a:t>2</a:t>
+            </a:r>
+          </a:p>
+        </p:txBody>
+      </p:sp>
+      <p:sp>
+        <p:nvSpPr>
+          <p:cNvPr id="18" name="Text 18"/>
+          <p:cNvSpPr txBox="1"/>
+          <p:nvPr/>
+        </p:nvSpPr>
+        <p:spPr>
+          <a:xfrm>
+            <a:off x="7040880" y="2971800"/>
+            <a:ext cx="4602175" cy="777240"/>
+          </a:xfrm>
+          <a:prstGeom prst="rect">
+            <a:avLst/>
+          </a:prstGeom>
+          <a:noFill/>
+          <a:ln>
+            <a:noFill/>
+          </a:ln>
+        </p:spPr>
+        <p:txBody>
+          <a:bodyPr wrap="square" lIns="0" tIns="0" rIns="0" bIns="0" rtlCol="0" anchor="t">
+            <a:noAutofit/>
+          </a:bodyPr>
+          <a:lstStyle/>
+          <a:p>
+            <a:pPr algn="l">
+              <a:spcAft>
+                <a:spcPts val="200"/>
+              </a:spcAft>
+              <a:buNone/>
+            </a:pPr>
+            <a:r>
+              <a:rPr lang="de-CH" sz="1700" b="1" dirty="0">
                 <a:solidFill>
                   <a:srgbClr val="1F2328"/>
                 </a:solidFill>
                 <a:latin typeface="Arial"/>
                 <a:cs typeface="Arial"/>
               </a:rPr>
-              <a:t>40+ parallele Sitzungen</a:t>
-            </a:r>
-          </a:p>
-        </p:txBody>
-      </p:sp>
-      <p:sp>
-        <p:nvSpPr>
-          <p:cNvPr id="23" name="Text 23"/>
+              <a:t>Leise und sparsam</a:t>
+            </a:r>
+          </a:p>
+          <a:p>
+            <a:pPr algn="l">
+              <a:lnSpc>
+                <a:spcPct val="105000"/>
+              </a:lnSpc>
+              <a:spcAft>
+                <a:spcPts val="0"/>
+              </a:spcAft>
+              <a:buNone/>
+            </a:pPr>
+            <a:r>
+              <a:rPr lang="de-CH" sz="1350" dirty="0">
+                <a:solidFill>
+                  <a:srgbClr val="5B6470"/>
+                </a:solidFill>
+                <a:latin typeface="Arial"/>
+                <a:cs typeface="Arial"/>
+              </a:rPr>
+              <a:t>Steht im Büro und braucht nur einen Bruchteil des Stroms eines GPU-Servers.</a:t>
+            </a:r>
+          </a:p>
+        </p:txBody>
+      </p:sp>
+      <p:sp>
+        <p:nvSpPr>
+          <p:cNvPr id="19" name="Shape 19"/>
+          <p:cNvSpPr/>
+          <p:nvPr/>
+        </p:nvSpPr>
+        <p:spPr>
+          <a:xfrm>
+            <a:off x="6446520" y="3886200"/>
+            <a:ext cx="420624" cy="420624"/>
+          </a:xfrm>
+          <a:prstGeom prst="ellipse">
+            <a:avLst/>
+          </a:prstGeom>
+          <a:solidFill>
+            <a:srgbClr val="D52B1E"/>
+          </a:solidFill>
+          <a:ln>
+            <a:noFill/>
+          </a:ln>
+        </p:spPr>
+        <p:txBody>
+          <a:bodyPr wrap="square" lIns="0" tIns="0" rIns="0" bIns="0" rtlCol="0" anchor="ctr">
+            <a:noAutofit/>
+          </a:bodyPr>
+          <a:lstStyle/>
+          <a:p>
+            <a:pPr algn="ctr">
+              <a:spcAft>
+                <a:spcPts val="0"/>
+              </a:spcAft>
+              <a:buNone/>
+            </a:pPr>
+            <a:r>
+              <a:rPr lang="de-CH" sz="1500" b="1" dirty="0">
+                <a:solidFill>
+                  <a:srgbClr val="FFFFFF"/>
+                </a:solidFill>
+                <a:latin typeface="Arial"/>
+                <a:cs typeface="Arial"/>
+              </a:rPr>
+              <a:t>3</a:t>
+            </a:r>
+          </a:p>
+        </p:txBody>
+      </p:sp>
+      <p:sp>
+        <p:nvSpPr>
+          <p:cNvPr id="20" name="Text 20"/>
           <p:cNvSpPr txBox="1"/>
           <p:nvPr/>
         </p:nvSpPr>
         <p:spPr>
           <a:xfrm>
-            <a:off x="8478317" y="4663440"/>
-            <a:ext cx="2844698" cy="594360"/>
+            <a:off x="7040880" y="3840480"/>
+            <a:ext cx="4602175" cy="777240"/>
           </a:xfrm>
           <a:prstGeom prst="rect">
             <a:avLst/>
@@ -2464,26 +2380,245 @@
           </a:ln>
         </p:spPr>
         <p:txBody>
-          <a:bodyPr wrap="square" lIns="0" tIns="0" rIns="0" bIns="0" rtlCol="0" anchor="ctr">
-            <a:noAutofit/>
-          </a:bodyPr>
-          <a:lstStyle/>
-          <a:p>
-            <a:pPr algn="l">
-              <a:spcAft>
-                <a:spcPts val="0"/>
-              </a:spcAft>
-              <a:buNone/>
-            </a:pPr>
-            <a:r>
-              <a:rPr lang="de-CH" sz="2800" b="1" dirty="0">
+          <a:bodyPr wrap="square" lIns="0" tIns="0" rIns="0" bIns="0" rtlCol="0" anchor="t">
+            <a:noAutofit/>
+          </a:bodyPr>
+          <a:lstStyle/>
+          <a:p>
+            <a:pPr algn="l">
+              <a:spcAft>
+                <a:spcPts val="200"/>
+              </a:spcAft>
+              <a:buNone/>
+            </a:pPr>
+            <a:r>
+              <a:rPr lang="de-CH" sz="1700" b="1" dirty="0">
                 <a:solidFill>
                   <a:srgbClr val="1F2328"/>
                 </a:solidFill>
                 <a:latin typeface="Arial"/>
                 <a:cs typeface="Arial"/>
               </a:rPr>
-              <a:t>CHF 90–130k</a:t>
+              <a:t>Ausfallsicher</a:t>
+            </a:r>
+          </a:p>
+          <a:p>
+            <a:pPr algn="l">
+              <a:lnSpc>
+                <a:spcPct val="105000"/>
+              </a:lnSpc>
+              <a:spcAft>
+                <a:spcPts val="0"/>
+              </a:spcAft>
+              <a:buNone/>
+            </a:pPr>
+            <a:r>
+              <a:rPr lang="de-CH" sz="1350" dirty="0">
+                <a:solidFill>
+                  <a:srgbClr val="5B6470"/>
+                </a:solidFill>
+                <a:latin typeface="Arial"/>
+                <a:cs typeface="Arial"/>
+              </a:rPr>
+              <a:t>Zwei Geräte teilen sich die Last. Fällt eines aus, übernimmt das andere.</a:t>
+            </a:r>
+          </a:p>
+        </p:txBody>
+      </p:sp>
+      <p:sp>
+        <p:nvSpPr>
+          <p:cNvPr id="21" name="Shape 21"/>
+          <p:cNvSpPr/>
+          <p:nvPr/>
+        </p:nvSpPr>
+        <p:spPr>
+          <a:xfrm>
+            <a:off x="6446520" y="4846320"/>
+            <a:ext cx="1610258" cy="914400"/>
+          </a:xfrm>
+          <a:prstGeom prst="roundRect">
+            <a:avLst>
+              <a:gd name="adj" fmla="val 9000"/>
+            </a:avLst>
+          </a:prstGeom>
+          <a:solidFill>
+            <a:srgbClr val="F2F3F5"/>
+          </a:solidFill>
+          <a:ln>
+            <a:noFill/>
+          </a:ln>
+        </p:spPr>
+        <p:txBody>
+          <a:bodyPr wrap="square" lIns="91440" tIns="73152" rIns="91440" bIns="73152" rtlCol="0" anchor="ctr">
+            <a:noAutofit/>
+          </a:bodyPr>
+          <a:lstStyle/>
+          <a:p>
+            <a:pPr algn="ctr">
+              <a:spcAft>
+                <a:spcPts val="100"/>
+              </a:spcAft>
+              <a:buNone/>
+            </a:pPr>
+            <a:r>
+              <a:rPr lang="de-CH" sz="2400" b="1" dirty="0">
+                <a:solidFill>
+                  <a:srgbClr val="D52B1E"/>
+                </a:solidFill>
+                <a:latin typeface="Arial"/>
+                <a:cs typeface="Arial"/>
+              </a:rPr>
+              <a:t>~100</a:t>
+            </a:r>
+          </a:p>
+          <a:p>
+            <a:pPr algn="ctr">
+              <a:spcAft>
+                <a:spcPts val="0"/>
+              </a:spcAft>
+              <a:buNone/>
+            </a:pPr>
+            <a:r>
+              <a:rPr lang="de-CH" sz="1150" dirty="0">
+                <a:solidFill>
+                  <a:srgbClr val="5B6470"/>
+                </a:solidFill>
+                <a:latin typeface="Arial"/>
+                <a:cs typeface="Arial"/>
+              </a:rPr>
+              <a:t>Nutzer</a:t>
+            </a:r>
+          </a:p>
+        </p:txBody>
+      </p:sp>
+      <p:sp>
+        <p:nvSpPr>
+          <p:cNvPr id="22" name="Shape 22"/>
+          <p:cNvSpPr/>
+          <p:nvPr/>
+        </p:nvSpPr>
+        <p:spPr>
+          <a:xfrm>
+            <a:off x="8239658" y="4846320"/>
+            <a:ext cx="1610258" cy="914400"/>
+          </a:xfrm>
+          <a:prstGeom prst="roundRect">
+            <a:avLst>
+              <a:gd name="adj" fmla="val 9000"/>
+            </a:avLst>
+          </a:prstGeom>
+          <a:solidFill>
+            <a:srgbClr val="F2F3F5"/>
+          </a:solidFill>
+          <a:ln>
+            <a:noFill/>
+          </a:ln>
+        </p:spPr>
+        <p:txBody>
+          <a:bodyPr wrap="square" lIns="91440" tIns="73152" rIns="91440" bIns="73152" rtlCol="0" anchor="ctr">
+            <a:noAutofit/>
+          </a:bodyPr>
+          <a:lstStyle/>
+          <a:p>
+            <a:pPr algn="ctr">
+              <a:spcAft>
+                <a:spcPts val="100"/>
+              </a:spcAft>
+              <a:buNone/>
+            </a:pPr>
+            <a:r>
+              <a:rPr lang="de-CH" sz="2400" b="1" dirty="0">
+                <a:solidFill>
+                  <a:srgbClr val="D52B1E"/>
+                </a:solidFill>
+                <a:latin typeface="Arial"/>
+                <a:cs typeface="Arial"/>
+              </a:rPr>
+              <a:t>~8</a:t>
+            </a:r>
+          </a:p>
+          <a:p>
+            <a:pPr algn="ctr">
+              <a:spcAft>
+                <a:spcPts val="0"/>
+              </a:spcAft>
+              <a:buNone/>
+            </a:pPr>
+            <a:r>
+              <a:rPr lang="de-CH" sz="1150" dirty="0">
+                <a:solidFill>
+                  <a:srgbClr val="5B6470"/>
+                </a:solidFill>
+                <a:latin typeface="Arial"/>
+                <a:cs typeface="Arial"/>
+              </a:rPr>
+              <a:t>parallele Sitzungen</a:t>
+            </a:r>
+          </a:p>
+        </p:txBody>
+      </p:sp>
+      <p:sp>
+        <p:nvSpPr>
+          <p:cNvPr id="23" name="Shape 23"/>
+          <p:cNvSpPr/>
+          <p:nvPr/>
+        </p:nvSpPr>
+        <p:spPr>
+          <a:xfrm>
+            <a:off x="10032797" y="4846320"/>
+            <a:ext cx="1610258" cy="914400"/>
+          </a:xfrm>
+          <a:prstGeom prst="roundRect">
+            <a:avLst>
+              <a:gd name="adj" fmla="val 9000"/>
+            </a:avLst>
+          </a:prstGeom>
+          <a:solidFill>
+            <a:srgbClr val="F2F3F5"/>
+          </a:solidFill>
+          <a:ln>
+            <a:noFill/>
+          </a:ln>
+        </p:spPr>
+        <p:txBody>
+          <a:bodyPr wrap="square" lIns="91440" tIns="73152" rIns="91440" bIns="73152" rtlCol="0" anchor="ctr">
+            <a:noAutofit/>
+          </a:bodyPr>
+          <a:lstStyle/>
+          <a:p>
+            <a:pPr algn="ctr">
+              <a:spcAft>
+                <a:spcPts val="100"/>
+              </a:spcAft>
+              <a:buNone/>
+            </a:pPr>
+            <a:r>
+              <a:rPr lang="de-CH" sz="2400" b="1" dirty="0">
+                <a:solidFill>
+                  <a:srgbClr val="D52B1E"/>
+                </a:solidFill>
+                <a:latin typeface="Arial"/>
+                <a:cs typeface="Arial"/>
+              </a:rPr>
+              <a:t>4–6</a:t>
+            </a:r>
+          </a:p>
+          <a:p>
+            <a:pPr algn="ctr">
+              <a:spcAft>
+                <a:spcPts val="0"/>
+              </a:spcAft>
+              <a:buNone/>
+            </a:pPr>
+            <a:r>
+              <a:rPr lang="de-CH" sz="1150" dirty="0">
+                <a:solidFill>
+                  <a:srgbClr val="5B6470"/>
+                </a:solidFill>
+                <a:latin typeface="Arial"/>
+                <a:cs typeface="Arial"/>
+              </a:rPr>
+              <a:t>Wochen bis Go-live</a:t>
             </a:r>
           </a:p>
         </p:txBody>
@@ -2496,8 +2631,8 @@
         </p:nvSpPr>
         <p:spPr>
           <a:xfrm>
-            <a:off x="548640" y="5760720"/>
-            <a:ext cx="11094415" cy="411480"/>
+            <a:off x="548640" y="5989320"/>
+            <a:ext cx="11094415" cy="502920"/>
           </a:xfrm>
           <a:prstGeom prst="rect">
             <a:avLst/>
@@ -2514,74 +2649,23 @@
           <a:lstStyle/>
           <a:p>
             <a:pPr algn="l">
-              <a:spcAft>
-                <a:spcPts val="0"/>
-              </a:spcAft>
-              <a:buNone/>
-            </a:pPr>
-            <a:r>
-              <a:rPr lang="de-CH" sz="1500" b="1" dirty="0">
-                <a:solidFill>
-                  <a:srgbClr val="1F2328"/>
-                </a:solidFill>
-                <a:latin typeface="Arial"/>
-                <a:cs typeface="Arial"/>
-              </a:rPr>
-              <a:t>Einführung in 6–8 Wochen</a:t>
-            </a:r>
-            <a:r>
-              <a:rPr lang="de-CH" sz="1500" dirty="0">
+              <a:lnSpc>
+                <a:spcPct val="105000"/>
+              </a:lnSpc>
+              <a:spcAft>
+                <a:spcPts val="0"/>
+              </a:spcAft>
+              <a:buNone/>
+            </a:pPr>
+            <a:r>
+              <a:rPr lang="de-CH" sz="1050" dirty="0">
                 <a:solidFill>
                   <a:srgbClr val="5B6470"/>
                 </a:solidFill>
                 <a:latin typeface="Arial"/>
                 <a:cs typeface="Arial"/>
               </a:rPr>
-              <a:t>   ·   Updates offline und signiert   ·   Support nur über Ihr VPN</a:t>
-            </a:r>
-          </a:p>
-        </p:txBody>
-      </p:sp>
-      <p:sp>
-        <p:nvSpPr>
-          <p:cNvPr id="25" name="Text 25"/>
-          <p:cNvSpPr txBox="1"/>
-          <p:nvPr/>
-        </p:nvSpPr>
-        <p:spPr>
-          <a:xfrm>
-            <a:off x="548640" y="6217920"/>
-            <a:ext cx="11094415" cy="320040"/>
-          </a:xfrm>
-          <a:prstGeom prst="rect">
-            <a:avLst/>
-          </a:prstGeom>
-          <a:noFill/>
-          <a:ln>
-            <a:noFill/>
-          </a:ln>
-        </p:spPr>
-        <p:txBody>
-          <a:bodyPr wrap="square" lIns="0" tIns="0" rIns="0" bIns="0" rtlCol="0" anchor="ctr">
-            <a:noAutofit/>
-          </a:bodyPr>
-          <a:lstStyle/>
-          <a:p>
-            <a:pPr algn="l">
-              <a:spcAft>
-                <a:spcPts val="0"/>
-              </a:spcAft>
-              <a:buNone/>
-            </a:pPr>
-            <a:r>
-              <a:rPr lang="de-CH" sz="1050" dirty="0">
-                <a:solidFill>
-                  <a:srgbClr val="5B6470"/>
-                </a:solidFill>
-                <a:latin typeface="Arial"/>
-                <a:cs typeface="Arial"/>
-              </a:rPr>
-              <a:t>Richtpreise nur Hardware, exkl. MWST, Stand September 2026. Kapazitäten sind Schätzungen und werden im Abnahmetest bestätigt.</a:t>
+              <a:t>Richtpreis Stand September 2026. Kapazitäten sind Schätzungen und werden im Abnahmetest bestätigt. Für Organisationen ab ca. 300 Nutzern: GPU-Server-Variante auf Anfrage.</a:t>
             </a:r>
           </a:p>
         </p:txBody>

</xml_diff>